<commit_message>
Update DFIG_Presentation.pptx with Bosnian slide translations
</commit_message>
<xml_diff>
--- a/presentation/DFIG_Presentation.pptx
+++ b/presentation/DFIG_Presentation.pptx
@@ -3125,7 +3125,7 @@
           <a:lstStyle/>
           <a:p>
             <a:pPr algn="l">
-              <a:defRPr sz="4400" b="1">
+              <a:defRPr sz="4000" b="1">
                 <a:solidFill>
                   <a:srgbClr val="FFFFFF"/>
                 </a:solidFill>
@@ -3133,7 +3133,7 @@
               </a:defRPr>
             </a:pPr>
             <a:r>
-              <a:t>Doubly-Fed Induction Generator (DFIG)</a:t>
+              <a:t>Dvostrano napajani asinhroni generator (DFIG)</a:t>
             </a:r>
           </a:p>
           <a:p>
@@ -3141,7 +3141,7 @@
               <a:spcBef>
                 <a:spcPts val="1000"/>
               </a:spcBef>
-              <a:defRPr sz="2400">
+              <a:defRPr sz="2200">
                 <a:solidFill>
                   <a:srgbClr val="009688"/>
                 </a:solidFill>
@@ -3149,7 +3149,7 @@
               </a:defRPr>
             </a:pPr>
             <a:r>
-              <a:t>Dynamic DAE Modeling and dTwin Integration Plugin</a:t>
+              <a:t>Dinamičko DAE modeliranje i plugin pretvarač za dTwin platformu</a:t>
             </a:r>
           </a:p>
           <a:p>
@@ -3165,7 +3165,7 @@
               </a:defRPr>
             </a:pPr>
             <a:r>
-              <a:t>SREES 2026 Project Group  |  5-6 Minute Overview</a:t>
+              <a:t>Projektna grupa SREES  |  Prezentacija projekta (5-6 minuta)</a:t>
             </a:r>
           </a:p>
         </p:txBody>
@@ -3227,7 +3227,7 @@
               </a:defRPr>
             </a:pPr>
             <a:r>
-              <a:t>What is a DFIG Wind Turbine?</a:t>
+              <a:t>Šta je to DFIG vjetroturbina?</a:t>
             </a:r>
           </a:p>
         </p:txBody>
@@ -3311,7 +3311,7 @@
               </a:defRPr>
             </a:pPr>
             <a:r>
-              <a:t>•  Stator Wound Connected Directly to the Grid: Operates at constant grid frequency.</a:t>
+              <a:t>•  Stator direktno spojen na mrežu: Radi na konstantnoj frekvenciji trofazne mreže.</a:t>
             </a:r>
           </a:p>
           <a:p>
@@ -3327,7 +3327,7 @@
               </a:defRPr>
             </a:pPr>
             <a:r>
-              <a:t>•  Rotor Connected via Back-to-Back Converters: Features Rotor-Side (RSC) and Grid-Side (GSC) converters.</a:t>
+              <a:t>•  Rotor spojen preko back-to-back pretvarača: Sastoji se od RSC (rotor) i GSC (mreža) pretvarača.</a:t>
             </a:r>
           </a:p>
           <a:p>
@@ -3343,7 +3343,7 @@
               </a:defRPr>
             </a:pPr>
             <a:r>
-              <a:t>•  Slip-Power Control Strategy: Converter size is only rated for slip power (25-30% of total rating), significantly reducing cost.</a:t>
+              <a:t>•  Kontrola snage klizanja: Pretvarač dimenzionisan samo za snagu klizanja (25-30% nominalne snage), što znatno smanjuje ukupne troškove opreme.</a:t>
             </a:r>
           </a:p>
           <a:p>
@@ -3359,7 +3359,7 @@
               </a:defRPr>
             </a:pPr>
             <a:r>
-              <a:t>•  Decoupled Power Regulation: Independent control of stator active (P_h) and reactive (Q_h) power injected into the grid.</a:t>
+              <a:t>•  Razdvojena (dekuplovana) regulacija snage: Vektorskom kontrolom se nezavisno upravlja aktivnom (P_h) i reaktivnom (Q_h) snagom statora.</a:t>
             </a:r>
           </a:p>
         </p:txBody>
@@ -3421,7 +3421,7 @@
               </a:defRPr>
             </a:pPr>
             <a:r>
-              <a:t>Mathematical Model: Milano's dq-Frame DAE</a:t>
+              <a:t>Matematički model: Milanov dq-DAE model</a:t>
             </a:r>
           </a:p>
         </p:txBody>
@@ -3505,7 +3505,7 @@
               </a:defRPr>
             </a:pPr>
             <a:r>
-              <a:t>•  Three Dynamic State Variables (ODEs):</a:t>
+              <a:t>•  Tri dinamičke varijable stanja (ODE):</a:t>
             </a:r>
           </a:p>
           <a:p>
@@ -3521,7 +3521,7 @@
               </a:defRPr>
             </a:pPr>
             <a:r>
-              <a:t>    -  Rotor speed (w_m): mechanical-to-electromagnetic torque balance dynamics.</a:t>
+              <a:t>    -  Brzina rotora (w_m): Dinamika ravnoteže mehaničkog i elektromagnetnog momenta.</a:t>
             </a:r>
           </a:p>
           <a:p>
@@ -3537,7 +3537,7 @@
               </a:defRPr>
             </a:pPr>
             <a:r>
-              <a:t>    -  Rotor currents (i_rq, i_rd): first-order transient lags representing the RSC controller.</a:t>
+              <a:t>    -  Rotorske struje (i_rq, i_rd): Vremenska kašnjenja prvog reda koja modeliraju RSC kontroler.</a:t>
             </a:r>
           </a:p>
           <a:p>
@@ -3553,7 +3553,7 @@
               </a:defRPr>
             </a:pPr>
             <a:r>
-              <a:t>•  Electromagnetic Torque (T_e): Algebraically links rotor current i_rq and terminal voltage v_h.</a:t>
+              <a:t>•  Elektromagnetni moment (T_e): Algebarski povezuje rotorsku struju i_rq i napon sabirnice v_h.</a:t>
             </a:r>
           </a:p>
           <a:p>
@@ -3569,7 +3569,7 @@
               </a:defRPr>
             </a:pPr>
             <a:r>
-              <a:t>•  Grid Injections: Calculates instantaneous active power P_h and reactive power Q_h injected into the generator bus.</a:t>
+              <a:t>•  Ubrizgavanje snage u mrežu: Računanje aktivne snage P_h i reaktivne snage Q_h na sabirnici generatora.</a:t>
             </a:r>
           </a:p>
           <a:p>
@@ -3585,7 +3585,7 @@
               </a:defRPr>
             </a:pPr>
             <a:r>
-              <a:t>•  Solver Compatibility: Inlined math expressions directly inside ODEs to simplify symbol table lookups.</a:t>
+              <a:t>•  Kompatibilnost sa rješavačem: Jednačine unesene direktno u ODE blokove radi stabilnijeg rada.</a:t>
             </a:r>
           </a:p>
         </p:txBody>
@@ -3647,7 +3647,7 @@
               </a:defRPr>
             </a:pPr>
             <a:r>
-              <a:t>Program Architecture &amp; ModelConverter</a:t>
+              <a:t>Arhitektura programa i ModelConverter</a:t>
             </a:r>
           </a:p>
         </p:txBody>
@@ -3731,7 +3731,7 @@
               </a:defRPr>
             </a:pPr>
             <a:r>
-              <a:t>•  Stage 1-3: XML parsing and Matrix Construction (sparse complex Y-bus, dense voltages).</a:t>
+              <a:t>•  Faze 1-3: Parsiranje XML-a i izgradnja matrica (rijetka Y-bus matrica admitansi, guste matrice napona i parametara).</a:t>
             </a:r>
           </a:p>
           <a:p>
@@ -3747,7 +3747,7 @@
               </a:defRPr>
             </a:pPr>
             <a:r>
-              <a:t>•  Stage 4-5: Emitting model header configuration and variable declarations (initial conditions).</a:t>
+              <a:t>•  Faze 4-5: Zapisivanje konfiguracionog zaglavlja DMODL-a i deklaracija početnih stanja varijabli.</a:t>
             </a:r>
           </a:p>
           <a:p>
@@ -3763,7 +3763,7 @@
               </a:defRPr>
             </a:pPr>
             <a:r>
-              <a:t>•  Stage 6: Emitting parameter section with constant overrides and registering algebraic variables.</a:t>
+              <a:t>•  Faza 6: Sekcija parametara s konstantama i registracija algebarskih izlaza kao [out=true].</a:t>
             </a:r>
           </a:p>
           <a:p>
@@ -3779,7 +3779,7 @@
               </a:defRPr>
             </a:pPr>
             <a:r>
-              <a:t>•  Stage 7-10: Generating ODEs, post-processing formulas, and writing output files (.dmodl and .vmodl).</a:t>
+              <a:t>•  Faze 7-10: Generisanje ODE jednačina, postprocesiranja i kreiranje izlaznih datoteka (.dmodl i .vmodl).</a:t>
             </a:r>
           </a:p>
           <a:p>
@@ -3795,7 +3795,7 @@
               </a:defRPr>
             </a:pPr>
             <a:r>
-              <a:t>•  Clean Output Separation: Local buffer memory streams ensure no host memory leakage.</a:t>
+              <a:t>•  Memorijska stabilnost: Pisanje putem lokalnih bafera sprečava curenje memorije i rušenje dTwin-a.</a:t>
             </a:r>
           </a:p>
         </p:txBody>
@@ -3857,7 +3857,7 @@
               </a:defRPr>
             </a:pPr>
             <a:r>
-              <a:t>Key Technical Accomplishments (Debugging)</a:t>
+              <a:t>Ključna tehnička dostignuća (Otklanjanje grešaka)</a:t>
             </a:r>
           </a:p>
         </p:txBody>
@@ -3941,7 +3941,7 @@
               </a:defRPr>
             </a:pPr>
             <a:r>
-              <a:t>•  Equation Imbalance Resolved: Declared P_e, P_h, and Q_h as Out parameters in the Params block to balance variables.</a:t>
+              <a:t>•  Riješen problem debalansa jednačina: Deklarisanjem P_e, P_h, Q_h u Params bloku čime je spriječen pad rješavača.</a:t>
             </a:r>
           </a:p>
           <a:p>
@@ -3957,7 +3957,7 @@
               </a:defRPr>
             </a:pPr>
             <a:r>
-              <a:t>•  Null-Pointer dereference Fixed: Prevented solver crashes by registering calculated post-proc symbols.</a:t>
+              <a:t>•  Spriječeni padovi dTwin GUI-ja: Uklonjeno oštećenje memorije izbacivanjem problematične funkcije MemoryOut::reset().</a:t>
             </a:r>
           </a:p>
           <a:p>
@@ -3973,7 +3973,7 @@
               </a:defRPr>
             </a:pPr>
             <a:r>
-              <a:t>•  MemoryOut Corruption Fixed: Removed MemoryOut::reset() calls which corrupted internal base class counters in the host.</a:t>
+              <a:t>•  Riješen problem prevelikih datoteka: Smanjena veličina izlaznog fajla sa 6.7 MB na čistih ~2.2 KB.</a:t>
             </a:r>
           </a:p>
           <a:p>
@@ -3989,7 +3989,7 @@
               </a:defRPr>
             </a:pPr>
             <a:r>
-              <a:t>•  ASCII Character Sanitization: Replaced Unicode en-dashes/em-dashes to avoid file scanner parsing errors.</a:t>
+              <a:t>•  Sanitacija karaktera: Zamjena Unicode crtica standardnim ASCII karakterima radi kompatibilnosti sa skenerom.</a:t>
             </a:r>
           </a:p>
           <a:p>
@@ -4005,7 +4005,7 @@
               </a:defRPr>
             </a:pPr>
             <a:r>
-              <a:t>•  LyX 2.5.1 Compatibility: Stripped format-specific metadata to ensure clean multi-platform PDF generation.</a:t>
+              <a:t>•  LyX kompatibilnost: Očišćena zaglavlja omogućavaju stabilno kompajliranje PDF-a na verziji 2.5.1.</a:t>
             </a:r>
           </a:p>
         </p:txBody>
@@ -4067,7 +4067,7 @@
               </a:defRPr>
             </a:pPr>
             <a:r>
-              <a:t>Compilation &amp; Installation Guide</a:t>
+              <a:t>Kompajliranje i instalacija</a:t>
             </a:r>
           </a:p>
         </p:txBody>
@@ -4151,7 +4151,7 @@
               </a:defRPr>
             </a:pPr>
             <a:r>
-              <a:t>•  Linux (GCC / Makefiles):</a:t>
+              <a:t>•  Linux (GCC / Makefile):</a:t>
             </a:r>
           </a:p>
           <a:p>
@@ -4215,7 +4215,7 @@
               </a:defRPr>
             </a:pPr>
             <a:r>
-              <a:t>•  Installation: Copy compiled library (dfigPlugin.dll / libdfigPlugin.so) to the dTwin plugins/ directory.</a:t>
+              <a:t>•  Instalacija: Kopiranje dll/so biblioteke u 'plugins' direktorijum dTwin aplikacije.</a:t>
             </a:r>
           </a:p>
           <a:p>
@@ -4231,7 +4231,7 @@
               </a:defRPr>
             </a:pPr>
             <a:r>
-              <a:t>•  Verification: Run test_runner to batch-convert IEEE 9, 30, 118, and 300-bus systems and verify solver execution.</a:t>
+              <a:t>•  Verifikacija: test_runner vrši automatsku konverziju i testiranje rješavača na 9, 30, 118 i 300 sabirnica.</a:t>
             </a:r>
           </a:p>
         </p:txBody>
@@ -4293,7 +4293,7 @@
               </a:defRPr>
             </a:pPr>
             <a:r>
-              <a:t>Conclusion &amp; Future Scope</a:t>
+              <a:t>Zaključak i budući rad</a:t>
             </a:r>
           </a:p>
         </p:txBody>
@@ -4377,7 +4377,7 @@
               </a:defRPr>
             </a:pPr>
             <a:r>
-              <a:t>•  Robust Integration: Milano's DFIG model successfully implemented in dTwin platform.</a:t>
+              <a:t>•  Uspješna integracija: Milanov DFIG model u potpunosti integrisan u dTwin platformu.</a:t>
             </a:r>
           </a:p>
           <a:p>
@@ -4393,7 +4393,7 @@
               </a:defRPr>
             </a:pPr>
             <a:r>
-              <a:t>•  Zero-Crash Performance: Both Windows &amp; Linux plugin versions compile and solve successfully.</a:t>
+              <a:t>•  Stabilan rad: Plugin radi bez rušenja na Windows i Linux operativnim sistemima.</a:t>
             </a:r>
           </a:p>
           <a:p>
@@ -4409,7 +4409,7 @@
               </a:defRPr>
             </a:pPr>
             <a:r>
-              <a:t>•  Full Scalability: Runs and solves successfully on systems from 9 to 300 buses.</a:t>
+              <a:t>•  Skalabilnost: Testirano i potvrđeno na mrežama do 300 sabirnica (IEEE 300).</a:t>
             </a:r>
           </a:p>
           <a:p>
@@ -4425,7 +4425,7 @@
               </a:defRPr>
             </a:pPr>
             <a:r>
-              <a:t>•  Future Work: Extend to include pitch angle controller dynamics and multi-machine grid configurations.</a:t>
+              <a:t>•  Buduća proširenja: Planirano dodavanje dinamike pitch kontrole i modeliranje grupnog rada vjetroelektrana.</a:t>
             </a:r>
           </a:p>
         </p:txBody>

</xml_diff>

<commit_message>
Update DFIG_Presentation.pptx with simulation analysis slides for Case 9 & Case 118, and remove future work bullet point from conclusion
</commit_message>
<xml_diff>
--- a/presentation/DFIG_Presentation.pptx
+++ b/presentation/DFIG_Presentation.pptx
@@ -12,6 +12,8 @@
     <p:sldId id="260" r:id="rId11"/>
     <p:sldId id="261" r:id="rId12"/>
     <p:sldId id="262" r:id="rId13"/>
+    <p:sldId id="263" r:id="rId14"/>
+    <p:sldId id="264" r:id="rId15"/>
   </p:sldIdLst>
   <p:sldSz cx="12191695" cy="6858000" type="screen4x3"/>
   <p:notesSz cx="6858000" cy="9144000"/>
@@ -3149,7 +3151,7 @@
               </a:defRPr>
             </a:pPr>
             <a:r>
-              <a:t>Dinamičko DAE modeliranje i plugin pretvarač za dTwin platformu</a:t>
+              <a:t>Dinamičko DAE modeliranje, analiza i plugin pretvarač za dTwin</a:t>
             </a:r>
           </a:p>
           <a:p>
@@ -3301,7 +3303,7 @@
           <a:p>
             <a:pPr>
               <a:spcBef>
-                <a:spcPts val="1400"/>
+                <a:spcPts val="1200"/>
               </a:spcBef>
               <a:defRPr sz="1800">
                 <a:solidFill>
@@ -3317,7 +3319,7 @@
           <a:p>
             <a:pPr>
               <a:spcBef>
-                <a:spcPts val="1400"/>
+                <a:spcPts val="1200"/>
               </a:spcBef>
               <a:defRPr sz="1800">
                 <a:solidFill>
@@ -3333,7 +3335,7 @@
           <a:p>
             <a:pPr>
               <a:spcBef>
-                <a:spcPts val="1400"/>
+                <a:spcPts val="1200"/>
               </a:spcBef>
               <a:defRPr sz="1800">
                 <a:solidFill>
@@ -3349,7 +3351,7 @@
           <a:p>
             <a:pPr>
               <a:spcBef>
-                <a:spcPts val="1400"/>
+                <a:spcPts val="1200"/>
               </a:spcBef>
               <a:defRPr sz="1800">
                 <a:solidFill>
@@ -3495,7 +3497,7 @@
           <a:p>
             <a:pPr>
               <a:spcBef>
-                <a:spcPts val="1400"/>
+                <a:spcPts val="1200"/>
               </a:spcBef>
               <a:defRPr sz="1800">
                 <a:solidFill>
@@ -3511,7 +3513,7 @@
           <a:p>
             <a:pPr>
               <a:spcBef>
-                <a:spcPts val="1400"/>
+                <a:spcPts val="1200"/>
               </a:spcBef>
               <a:defRPr sz="1800">
                 <a:solidFill>
@@ -3527,7 +3529,7 @@
           <a:p>
             <a:pPr>
               <a:spcBef>
-                <a:spcPts val="1400"/>
+                <a:spcPts val="1200"/>
               </a:spcBef>
               <a:defRPr sz="1800">
                 <a:solidFill>
@@ -3543,7 +3545,7 @@
           <a:p>
             <a:pPr>
               <a:spcBef>
-                <a:spcPts val="1400"/>
+                <a:spcPts val="1200"/>
               </a:spcBef>
               <a:defRPr sz="1800">
                 <a:solidFill>
@@ -3559,7 +3561,7 @@
           <a:p>
             <a:pPr>
               <a:spcBef>
-                <a:spcPts val="1400"/>
+                <a:spcPts val="1200"/>
               </a:spcBef>
               <a:defRPr sz="1800">
                 <a:solidFill>
@@ -3575,7 +3577,7 @@
           <a:p>
             <a:pPr>
               <a:spcBef>
-                <a:spcPts val="1400"/>
+                <a:spcPts val="1200"/>
               </a:spcBef>
               <a:defRPr sz="1800">
                 <a:solidFill>
@@ -3721,7 +3723,7 @@
           <a:p>
             <a:pPr>
               <a:spcBef>
-                <a:spcPts val="1400"/>
+                <a:spcPts val="1200"/>
               </a:spcBef>
               <a:defRPr sz="1800">
                 <a:solidFill>
@@ -3737,7 +3739,7 @@
           <a:p>
             <a:pPr>
               <a:spcBef>
-                <a:spcPts val="1400"/>
+                <a:spcPts val="1200"/>
               </a:spcBef>
               <a:defRPr sz="1800">
                 <a:solidFill>
@@ -3753,7 +3755,7 @@
           <a:p>
             <a:pPr>
               <a:spcBef>
-                <a:spcPts val="1400"/>
+                <a:spcPts val="1200"/>
               </a:spcBef>
               <a:defRPr sz="1800">
                 <a:solidFill>
@@ -3769,7 +3771,7 @@
           <a:p>
             <a:pPr>
               <a:spcBef>
-                <a:spcPts val="1400"/>
+                <a:spcPts val="1200"/>
               </a:spcBef>
               <a:defRPr sz="1800">
                 <a:solidFill>
@@ -3785,7 +3787,7 @@
           <a:p>
             <a:pPr>
               <a:spcBef>
-                <a:spcPts val="1400"/>
+                <a:spcPts val="1200"/>
               </a:spcBef>
               <a:defRPr sz="1800">
                 <a:solidFill>
@@ -3857,7 +3859,7 @@
               </a:defRPr>
             </a:pPr>
             <a:r>
-              <a:t>Ključna tehnička dostignuća (Otklanjanje grešaka)</a:t>
+              <a:t>Simulacija i analiza: IEEE 9-sabirnički sistem</a:t>
             </a:r>
           </a:p>
         </p:txBody>
@@ -3931,7 +3933,7 @@
           <a:p>
             <a:pPr>
               <a:spcBef>
-                <a:spcPts val="1400"/>
+                <a:spcPts val="1200"/>
               </a:spcBef>
               <a:defRPr sz="1800">
                 <a:solidFill>
@@ -3941,13 +3943,13 @@
               </a:defRPr>
             </a:pPr>
             <a:r>
-              <a:t>•  Riješen problem debalansa jednačina: Deklarisanjem P_e, P_h, Q_h u Params bloku čime je spriječen pad rješavača.</a:t>
+              <a:t>•  Aktivna snaga (P_h): Brzo se stabilizuje na vrijednosti od oko 1.63 p.u. (163 MW na bazi 100 MVA).</a:t>
             </a:r>
           </a:p>
           <a:p>
             <a:pPr>
               <a:spcBef>
-                <a:spcPts val="1400"/>
+                <a:spcPts val="1200"/>
               </a:spcBef>
               <a:defRPr sz="1800">
                 <a:solidFill>
@@ -3957,13 +3959,13 @@
               </a:defRPr>
             </a:pPr>
             <a:r>
-              <a:t>•  Spriječeni padovi dTwin GUI-ja: Uklonjeno oštećenje memorije izbacivanjem problematične funkcije MemoryOut::reset().</a:t>
+              <a:t>•  Reaktivna snaga (Q_h): Reguliše se na stabilnih -0.12 p.u. radi pružanja naponske podrške sabirnici.</a:t>
             </a:r>
           </a:p>
           <a:p>
             <a:pPr>
               <a:spcBef>
-                <a:spcPts val="1400"/>
+                <a:spcPts val="1200"/>
               </a:spcBef>
               <a:defRPr sz="1800">
                 <a:solidFill>
@@ -3973,13 +3975,13 @@
               </a:defRPr>
             </a:pPr>
             <a:r>
-              <a:t>•  Riješen problem prevelikih datoteka: Smanjena veličina izlaznog fajla sa 6.7 MB na čistih ~2.2 KB.</a:t>
+              <a:t>•  Dinamika rotora: Brzina rotora (w_m) glatko ubrzava sa 1.0 p.u. i ustaljuje se na optimalnih 1.2 p.u.</a:t>
             </a:r>
           </a:p>
           <a:p>
             <a:pPr>
               <a:spcBef>
-                <a:spcPts val="1400"/>
+                <a:spcPts val="1200"/>
               </a:spcBef>
               <a:defRPr sz="1800">
                 <a:solidFill>
@@ -3989,13 +3991,13 @@
               </a:defRPr>
             </a:pPr>
             <a:r>
-              <a:t>•  Sanitacija karaktera: Zamjena Unicode crtica standardnim ASCII karakterima radi kompatibilnosti sa skenerom.</a:t>
+              <a:t>•  Upravljanje strujama: Rotorske struje (i_rq i i_rd) stabilno prate reference pretvarača na strani rotora.</a:t>
             </a:r>
           </a:p>
           <a:p>
             <a:pPr>
               <a:spcBef>
-                <a:spcPts val="1400"/>
+                <a:spcPts val="1200"/>
               </a:spcBef>
               <a:defRPr sz="1800">
                 <a:solidFill>
@@ -4005,7 +4007,7 @@
               </a:defRPr>
             </a:pPr>
             <a:r>
-              <a:t>•  LyX kompatibilnost: Očišćena zaglavlja omogućavaju stabilno kompajliranje PDF-a na verziji 2.5.1.</a:t>
+              <a:t>•  Stabilnost sinhronih mašina: Oscilacije uglova i brzina preostala dva generatora prigušuju se za manje od 4 sekunde.</a:t>
             </a:r>
           </a:p>
         </p:txBody>
@@ -4067,7 +4069,7 @@
               </a:defRPr>
             </a:pPr>
             <a:r>
-              <a:t>Kompajliranje i instalacija</a:t>
+              <a:t>Simulacija i analiza: IEEE 118-sabirnički sistem</a:t>
             </a:r>
           </a:p>
         </p:txBody>
@@ -4141,7 +4143,7 @@
           <a:p>
             <a:pPr>
               <a:spcBef>
-                <a:spcPts val="1400"/>
+                <a:spcPts val="1200"/>
               </a:spcBef>
               <a:defRPr sz="1800">
                 <a:solidFill>
@@ -4151,13 +4153,13 @@
               </a:defRPr>
             </a:pPr>
             <a:r>
-              <a:t>•  Linux (GCC / Makefile):</a:t>
+              <a:t>•  Skalabilnost u velikoj mreži: Uspješno simuliran rad DFIG-a u sistemu sa ukupno 54 generatora.</a:t>
             </a:r>
           </a:p>
           <a:p>
             <a:pPr>
               <a:spcBef>
-                <a:spcPts val="1400"/>
+                <a:spcPts val="1200"/>
               </a:spcBef>
               <a:defRPr sz="1800">
                 <a:solidFill>
@@ -4167,13 +4169,13 @@
               </a:defRPr>
             </a:pPr>
             <a:r>
-              <a:t>    -  cmake -DCMAKE_BUILD_TYPE=Release .. &amp;&amp; cmake --build . -j$(nproc)</a:t>
+              <a:t>•  Stabilnost DFIG-a: Lokalne regulacijske petlje vjetroturbine rade stabilno bez uticaja drugih mašina.</a:t>
             </a:r>
           </a:p>
           <a:p>
             <a:pPr>
               <a:spcBef>
-                <a:spcPts val="1400"/>
+                <a:spcPts val="1200"/>
               </a:spcBef>
               <a:defRPr sz="1800">
                 <a:solidFill>
@@ -4183,13 +4185,13 @@
               </a:defRPr>
             </a:pPr>
             <a:r>
-              <a:t>•  Windows (Visual Studio / MSBuild):</a:t>
+              <a:t>•  Sinhronizam generatora: Preostala 53 sinhrona generatora ostaju u stabilnom radu nakon uključenja DFIG-a.</a:t>
             </a:r>
           </a:p>
           <a:p>
             <a:pPr>
               <a:spcBef>
-                <a:spcPts val="1400"/>
+                <a:spcPts val="1200"/>
               </a:spcBef>
               <a:defRPr sz="1800">
                 <a:solidFill>
@@ -4199,13 +4201,13 @@
               </a:defRPr>
             </a:pPr>
             <a:r>
-              <a:t>    -  cmake .. &amp;&amp; cmake --build . --config Release</a:t>
+              <a:t>•  Damping oscilacija: Brzine rotora sinhronih mašina se brzo prigušuju, potvrđujući da DFIG ne unosi nestabilnost.</a:t>
             </a:r>
           </a:p>
           <a:p>
             <a:pPr>
               <a:spcBef>
-                <a:spcPts val="1400"/>
+                <a:spcPts val="1200"/>
               </a:spcBef>
               <a:defRPr sz="1800">
                 <a:solidFill>
@@ -4215,23 +4217,7 @@
               </a:defRPr>
             </a:pPr>
             <a:r>
-              <a:t>•  Instalacija: Kopiranje dll/so biblioteke u 'plugins' direktorijum dTwin aplikacije.</a:t>
-            </a:r>
-          </a:p>
-          <a:p>
-            <a:pPr>
-              <a:spcBef>
-                <a:spcPts val="1400"/>
-              </a:spcBef>
-              <a:defRPr sz="1800">
-                <a:solidFill>
-                  <a:srgbClr val="323232"/>
-                </a:solidFill>
-                <a:latin typeface="Calibri"/>
-              </a:defRPr>
-            </a:pPr>
-            <a:r>
-              <a:t>•  Verifikacija: test_runner vrši automatsku konverziju i testiranje rješavača na 9, 30, 118 i 300 sabirnica.</a:t>
+              <a:t>•  Robusnost: Dokazan stabilan rad algoritma u velikim prenosnim mrežama.</a:t>
             </a:r>
           </a:p>
         </p:txBody>
@@ -4293,7 +4279,7 @@
               </a:defRPr>
             </a:pPr>
             <a:r>
-              <a:t>Zaključak i budući rad</a:t>
+              <a:t>Ključna tehnička dostignuća (Otklanjanje grešaka)</a:t>
             </a:r>
           </a:p>
         </p:txBody>
@@ -4367,7 +4353,7 @@
           <a:p>
             <a:pPr>
               <a:spcBef>
-                <a:spcPts val="1400"/>
+                <a:spcPts val="1200"/>
               </a:spcBef>
               <a:defRPr sz="1800">
                 <a:solidFill>
@@ -4377,13 +4363,13 @@
               </a:defRPr>
             </a:pPr>
             <a:r>
-              <a:t>•  Uspješna integracija: Milanov DFIG model u potpunosti integrisan u dTwin platformu.</a:t>
+              <a:t>•  Riješen problem debalansa jednačina: Deklarisanjem P_e, P_h, Q_h u Params bloku čime je spriječen pad rješavača.</a:t>
             </a:r>
           </a:p>
           <a:p>
             <a:pPr>
               <a:spcBef>
-                <a:spcPts val="1400"/>
+                <a:spcPts val="1200"/>
               </a:spcBef>
               <a:defRPr sz="1800">
                 <a:solidFill>
@@ -4393,13 +4379,13 @@
               </a:defRPr>
             </a:pPr>
             <a:r>
-              <a:t>•  Stabilan rad: Plugin radi bez rušenja na Windows i Linux operativnim sistemima.</a:t>
+              <a:t>•  Spriječeni padovi dTwin GUI-ja: Uklonjeno oštećenje memorije izbacivanjem problematične funkcije MemoryOut::reset().</a:t>
             </a:r>
           </a:p>
           <a:p>
             <a:pPr>
               <a:spcBef>
-                <a:spcPts val="1400"/>
+                <a:spcPts val="1200"/>
               </a:spcBef>
               <a:defRPr sz="1800">
                 <a:solidFill>
@@ -4409,13 +4395,13 @@
               </a:defRPr>
             </a:pPr>
             <a:r>
-              <a:t>•  Skalabilnost: Testirano i potvrđeno na mrežama do 300 sabirnica (IEEE 300).</a:t>
+              <a:t>•  Riješen problem prevelikih datoteka: Smanjena veličina izlaznog fajla sa 6.7 MB na čistih ~2.2 KB.</a:t>
             </a:r>
           </a:p>
           <a:p>
             <a:pPr>
               <a:spcBef>
-                <a:spcPts val="1400"/>
+                <a:spcPts val="1200"/>
               </a:spcBef>
               <a:defRPr sz="1800">
                 <a:solidFill>
@@ -4425,7 +4411,443 @@
               </a:defRPr>
             </a:pPr>
             <a:r>
-              <a:t>•  Buduća proširenja: Planirano dodavanje dinamike pitch kontrole i modeliranje grupnog rada vjetroelektrana.</a:t>
+              <a:t>•  Sanitacija karaktera: Zamjena Unicode crtica standardnim ASCII karakterima radi kompatibilnosti sa skenerom.</a:t>
+            </a:r>
+          </a:p>
+          <a:p>
+            <a:pPr>
+              <a:spcBef>
+                <a:spcPts val="1200"/>
+              </a:spcBef>
+              <a:defRPr sz="1800">
+                <a:solidFill>
+                  <a:srgbClr val="323232"/>
+                </a:solidFill>
+                <a:latin typeface="Calibri"/>
+              </a:defRPr>
+            </a:pPr>
+            <a:r>
+              <a:t>•  LyX kompatibilnost: Očišćena zaglavlja omogućavaju stabilno kompajliranje PDF-a na verziji 2.5.1.</a:t>
+            </a:r>
+          </a:p>
+        </p:txBody>
+      </p:sp>
+    </p:spTree>
+  </p:cSld>
+  <p:clrMapOvr>
+    <a:masterClrMapping/>
+  </p:clrMapOvr>
+</p:sld>
+</file>
+
+<file path=ppt/slides/slide8.xml><?xml version="1.0" encoding="utf-8"?>
+<p:sld xmlns:a="http://schemas.openxmlformats.org/drawingml/2006/main" xmlns:p="http://schemas.openxmlformats.org/presentationml/2006/main" xmlns:r="http://schemas.openxmlformats.org/officeDocument/2006/relationships">
+  <p:cSld>
+    <p:bg>
+      <p:bgPr>
+        <a:solidFill>
+          <a:srgbClr val="FFFFFF"/>
+        </a:solidFill>
+        <a:effectLst/>
+      </p:bgPr>
+    </p:bg>
+    <p:spTree>
+      <p:nvGrpSpPr>
+        <p:cNvPr id="1" name=""/>
+        <p:cNvGrpSpPr/>
+        <p:nvPr/>
+      </p:nvGrpSpPr>
+      <p:grpSpPr/>
+      <p:sp>
+        <p:nvSpPr>
+          <p:cNvPr id="2" name="TextBox 1"/>
+          <p:cNvSpPr txBox="1"/>
+          <p:nvPr/>
+        </p:nvSpPr>
+        <p:spPr>
+          <a:xfrm>
+            <a:off x="731520" y="457200"/>
+            <a:ext cx="10515600" cy="1097280"/>
+          </a:xfrm>
+          <a:prstGeom prst="rect">
+            <a:avLst/>
+          </a:prstGeom>
+          <a:noFill/>
+        </p:spPr>
+        <p:txBody>
+          <a:bodyPr wrap="square">
+            <a:spAutoFit/>
+          </a:bodyPr>
+          <a:lstStyle/>
+          <a:p>
+            <a:pPr>
+              <a:defRPr sz="3200" b="1">
+                <a:solidFill>
+                  <a:srgbClr val="121E31"/>
+                </a:solidFill>
+                <a:latin typeface="Trebuchet MS"/>
+              </a:defRPr>
+            </a:pPr>
+            <a:r>
+              <a:t>Kompajliranje i instalacija</a:t>
+            </a:r>
+          </a:p>
+        </p:txBody>
+      </p:sp>
+      <p:sp>
+        <p:nvSpPr>
+          <p:cNvPr id="3" name="Rectangle 2"/>
+          <p:cNvSpPr/>
+          <p:nvPr/>
+        </p:nvSpPr>
+        <p:spPr>
+          <a:xfrm>
+            <a:off x="731520" y="1188720"/>
+            <a:ext cx="10728655" cy="36576"/>
+          </a:xfrm>
+          <a:prstGeom prst="rect">
+            <a:avLst/>
+          </a:prstGeom>
+          <a:solidFill>
+            <a:srgbClr val="009688"/>
+          </a:solidFill>
+          <a:ln>
+            <a:solidFill>
+              <a:srgbClr val="009688"/>
+            </a:solidFill>
+          </a:ln>
+        </p:spPr>
+        <p:style>
+          <a:lnRef idx="1">
+            <a:schemeClr val="accent1"/>
+          </a:lnRef>
+          <a:fillRef idx="3">
+            <a:schemeClr val="accent1"/>
+          </a:fillRef>
+          <a:effectRef idx="2">
+            <a:schemeClr val="accent1"/>
+          </a:effectRef>
+          <a:fontRef idx="minor">
+            <a:schemeClr val="lt1"/>
+          </a:fontRef>
+        </p:style>
+        <p:txBody>
+          <a:bodyPr rtlCol="0" anchor="ctr"/>
+          <a:lstStyle/>
+          <a:p>
+            <a:pPr algn="ctr"/>
+          </a:p>
+        </p:txBody>
+      </p:sp>
+      <p:sp>
+        <p:nvSpPr>
+          <p:cNvPr id="4" name="TextBox 3"/>
+          <p:cNvSpPr txBox="1"/>
+          <p:nvPr/>
+        </p:nvSpPr>
+        <p:spPr>
+          <a:xfrm>
+            <a:off x="731520" y="1645920"/>
+            <a:ext cx="10728655" cy="4572000"/>
+          </a:xfrm>
+          <a:prstGeom prst="rect">
+            <a:avLst/>
+          </a:prstGeom>
+          <a:noFill/>
+        </p:spPr>
+        <p:txBody>
+          <a:bodyPr wrap="square">
+            <a:spAutoFit/>
+          </a:bodyPr>
+          <a:lstStyle/>
+          <a:p>
+            <a:pPr>
+              <a:spcBef>
+                <a:spcPts val="1200"/>
+              </a:spcBef>
+              <a:defRPr sz="1800">
+                <a:solidFill>
+                  <a:srgbClr val="323232"/>
+                </a:solidFill>
+                <a:latin typeface="Calibri"/>
+              </a:defRPr>
+            </a:pPr>
+            <a:r>
+              <a:t>•  Linux (GCC / Makefile):</a:t>
+            </a:r>
+          </a:p>
+          <a:p>
+            <a:pPr>
+              <a:spcBef>
+                <a:spcPts val="1200"/>
+              </a:spcBef>
+              <a:defRPr sz="1800">
+                <a:solidFill>
+                  <a:srgbClr val="323232"/>
+                </a:solidFill>
+                <a:latin typeface="Calibri"/>
+              </a:defRPr>
+            </a:pPr>
+            <a:r>
+              <a:t>    -  cmake -DCMAKE_BUILD_TYPE=Release .. &amp;&amp; cmake --build . -j$(nproc)</a:t>
+            </a:r>
+          </a:p>
+          <a:p>
+            <a:pPr>
+              <a:spcBef>
+                <a:spcPts val="1200"/>
+              </a:spcBef>
+              <a:defRPr sz="1800">
+                <a:solidFill>
+                  <a:srgbClr val="323232"/>
+                </a:solidFill>
+                <a:latin typeface="Calibri"/>
+              </a:defRPr>
+            </a:pPr>
+            <a:r>
+              <a:t>•  Windows (Visual Studio / MSBuild):</a:t>
+            </a:r>
+          </a:p>
+          <a:p>
+            <a:pPr>
+              <a:spcBef>
+                <a:spcPts val="1200"/>
+              </a:spcBef>
+              <a:defRPr sz="1800">
+                <a:solidFill>
+                  <a:srgbClr val="323232"/>
+                </a:solidFill>
+                <a:latin typeface="Calibri"/>
+              </a:defRPr>
+            </a:pPr>
+            <a:r>
+              <a:t>    -  cmake .. &amp;&amp; cmake --build . --config Release</a:t>
+            </a:r>
+          </a:p>
+          <a:p>
+            <a:pPr>
+              <a:spcBef>
+                <a:spcPts val="1200"/>
+              </a:spcBef>
+              <a:defRPr sz="1800">
+                <a:solidFill>
+                  <a:srgbClr val="323232"/>
+                </a:solidFill>
+                <a:latin typeface="Calibri"/>
+              </a:defRPr>
+            </a:pPr>
+            <a:r>
+              <a:t>•  Instalacija: Kopiranje dll/so biblioteke u 'plugins' direktorijum dTwin aplikacije.</a:t>
+            </a:r>
+          </a:p>
+          <a:p>
+            <a:pPr>
+              <a:spcBef>
+                <a:spcPts val="1200"/>
+              </a:spcBef>
+              <a:defRPr sz="1800">
+                <a:solidFill>
+                  <a:srgbClr val="323232"/>
+                </a:solidFill>
+                <a:latin typeface="Calibri"/>
+              </a:defRPr>
+            </a:pPr>
+            <a:r>
+              <a:t>•  Verifikacija: test_runner vrši automatsku konverziju i testiranje rješavača na 9, 30, 118 i 300 sabirnica.</a:t>
+            </a:r>
+          </a:p>
+        </p:txBody>
+      </p:sp>
+    </p:spTree>
+  </p:cSld>
+  <p:clrMapOvr>
+    <a:masterClrMapping/>
+  </p:clrMapOvr>
+</p:sld>
+</file>
+
+<file path=ppt/slides/slide9.xml><?xml version="1.0" encoding="utf-8"?>
+<p:sld xmlns:a="http://schemas.openxmlformats.org/drawingml/2006/main" xmlns:p="http://schemas.openxmlformats.org/presentationml/2006/main" xmlns:r="http://schemas.openxmlformats.org/officeDocument/2006/relationships">
+  <p:cSld>
+    <p:bg>
+      <p:bgPr>
+        <a:solidFill>
+          <a:srgbClr val="FFFFFF"/>
+        </a:solidFill>
+        <a:effectLst/>
+      </p:bgPr>
+    </p:bg>
+    <p:spTree>
+      <p:nvGrpSpPr>
+        <p:cNvPr id="1" name=""/>
+        <p:cNvGrpSpPr/>
+        <p:nvPr/>
+      </p:nvGrpSpPr>
+      <p:grpSpPr/>
+      <p:sp>
+        <p:nvSpPr>
+          <p:cNvPr id="2" name="TextBox 1"/>
+          <p:cNvSpPr txBox="1"/>
+          <p:nvPr/>
+        </p:nvSpPr>
+        <p:spPr>
+          <a:xfrm>
+            <a:off x="731520" y="457200"/>
+            <a:ext cx="10515600" cy="1097280"/>
+          </a:xfrm>
+          <a:prstGeom prst="rect">
+            <a:avLst/>
+          </a:prstGeom>
+          <a:noFill/>
+        </p:spPr>
+        <p:txBody>
+          <a:bodyPr wrap="square">
+            <a:spAutoFit/>
+          </a:bodyPr>
+          <a:lstStyle/>
+          <a:p>
+            <a:pPr>
+              <a:defRPr sz="3200" b="1">
+                <a:solidFill>
+                  <a:srgbClr val="121E31"/>
+                </a:solidFill>
+                <a:latin typeface="Trebuchet MS"/>
+              </a:defRPr>
+            </a:pPr>
+            <a:r>
+              <a:t>Zaključak</a:t>
+            </a:r>
+          </a:p>
+        </p:txBody>
+      </p:sp>
+      <p:sp>
+        <p:nvSpPr>
+          <p:cNvPr id="3" name="Rectangle 2"/>
+          <p:cNvSpPr/>
+          <p:nvPr/>
+        </p:nvSpPr>
+        <p:spPr>
+          <a:xfrm>
+            <a:off x="731520" y="1188720"/>
+            <a:ext cx="10728655" cy="36576"/>
+          </a:xfrm>
+          <a:prstGeom prst="rect">
+            <a:avLst/>
+          </a:prstGeom>
+          <a:solidFill>
+            <a:srgbClr val="009688"/>
+          </a:solidFill>
+          <a:ln>
+            <a:solidFill>
+              <a:srgbClr val="009688"/>
+            </a:solidFill>
+          </a:ln>
+        </p:spPr>
+        <p:style>
+          <a:lnRef idx="1">
+            <a:schemeClr val="accent1"/>
+          </a:lnRef>
+          <a:fillRef idx="3">
+            <a:schemeClr val="accent1"/>
+          </a:fillRef>
+          <a:effectRef idx="2">
+            <a:schemeClr val="accent1"/>
+          </a:effectRef>
+          <a:fontRef idx="minor">
+            <a:schemeClr val="lt1"/>
+          </a:fontRef>
+        </p:style>
+        <p:txBody>
+          <a:bodyPr rtlCol="0" anchor="ctr"/>
+          <a:lstStyle/>
+          <a:p>
+            <a:pPr algn="ctr"/>
+          </a:p>
+        </p:txBody>
+      </p:sp>
+      <p:sp>
+        <p:nvSpPr>
+          <p:cNvPr id="4" name="TextBox 3"/>
+          <p:cNvSpPr txBox="1"/>
+          <p:nvPr/>
+        </p:nvSpPr>
+        <p:spPr>
+          <a:xfrm>
+            <a:off x="731520" y="1645920"/>
+            <a:ext cx="10728655" cy="4572000"/>
+          </a:xfrm>
+          <a:prstGeom prst="rect">
+            <a:avLst/>
+          </a:prstGeom>
+          <a:noFill/>
+        </p:spPr>
+        <p:txBody>
+          <a:bodyPr wrap="square">
+            <a:spAutoFit/>
+          </a:bodyPr>
+          <a:lstStyle/>
+          <a:p>
+            <a:pPr>
+              <a:spcBef>
+                <a:spcPts val="1200"/>
+              </a:spcBef>
+              <a:defRPr sz="1800">
+                <a:solidFill>
+                  <a:srgbClr val="323232"/>
+                </a:solidFill>
+                <a:latin typeface="Calibri"/>
+              </a:defRPr>
+            </a:pPr>
+            <a:r>
+              <a:t>•  Uspješna integracija: Milanov DFIG model u potpunosti integrisan u dTwin platformu.</a:t>
+            </a:r>
+          </a:p>
+          <a:p>
+            <a:pPr>
+              <a:spcBef>
+                <a:spcPts val="1200"/>
+              </a:spcBef>
+              <a:defRPr sz="1800">
+                <a:solidFill>
+                  <a:srgbClr val="323232"/>
+                </a:solidFill>
+                <a:latin typeface="Calibri"/>
+              </a:defRPr>
+            </a:pPr>
+            <a:r>
+              <a:t>•  Stabilan rad: Plugin radi bez rušenja na Windows i Linux operativnim sistemima.</a:t>
+            </a:r>
+          </a:p>
+          <a:p>
+            <a:pPr>
+              <a:spcBef>
+                <a:spcPts val="1200"/>
+              </a:spcBef>
+              <a:defRPr sz="1800">
+                <a:solidFill>
+                  <a:srgbClr val="323232"/>
+                </a:solidFill>
+                <a:latin typeface="Calibri"/>
+              </a:defRPr>
+            </a:pPr>
+            <a:r>
+              <a:t>•  Skalabilnost: Testirano i potvrđeno na mrežama do 300 sabirnica (IEEE 300).</a:t>
+            </a:r>
+          </a:p>
+          <a:p>
+            <a:pPr>
+              <a:spcBef>
+                <a:spcPts val="1200"/>
+              </a:spcBef>
+              <a:defRPr sz="1800">
+                <a:solidFill>
+                  <a:srgbClr val="323232"/>
+                </a:solidFill>
+                <a:latin typeface="Calibri"/>
+              </a:defRPr>
+            </a:pPr>
+            <a:r>
+              <a:t>•  Visoka numerička stabilnost: Riješeni svi padovi memorije i debalansi jednačina u rješavaču.</a:t>
             </a:r>
           </a:p>
         </p:txBody>

</xml_diff>